<commit_message>
System Design vi: fix three P2 review findings on sd-11-018, 019, 021 (idempotence wording, repository versus deployment, interface endpoint scope)
Co-Authored-By: Claude Sonnet 5.5 <noreply@anthropic.com>
Claude-Session: https://claude.ai/code/session_01FUEjJx1iJbs8YafmDVXup4
</commit_message>
<xml_diff>
--- a/system-design-101/vi/lessons/sd-11-018/slides/sd-11-018.pptx
+++ b/system-design-101/vi/lessons/sd-11-018/slides/sd-11-018.pptx
@@ -8326,7 +8326,7 @@
                       <a:r>
                         <a:rPr lang="en-US" sz="2850" b="1" dirty="0">
                           <a:solidFill>
-                            <a:srgbClr val="F3EEE3"/>
+                            <a:srgbClr val="FFFFFF"/>
                           </a:solidFill>
                           <a:latin typeface="Be Vietnam Pro" pitchFamily="34" charset="0"/>
                           <a:ea typeface="Be Vietnam Pro" pitchFamily="34" charset="-122"/>
@@ -8337,7 +8337,7 @@
                       <a:endParaRPr lang="en-US" sz="1200" dirty="0"/>
                     </a:p>
                   </a:txBody>
-                  <a:tcPr marL="228600" marR="228600" marT="228600" marB="228600">
+                  <a:tcPr marL="76200" marR="76200" marT="76200" marB="76200">
                     <a:lnL w="9525" cap="flat" cmpd="sng" algn="ctr">
                       <a:solidFill>
                         <a:srgbClr val="DDD5C1"/>
@@ -8375,7 +8375,7 @@
                       <a:r>
                         <a:rPr lang="en-US" sz="2850" b="1" dirty="0" spc="-14" kern="0">
                           <a:solidFill>
-                            <a:srgbClr val="F3EEE3"/>
+                            <a:srgbClr val="FFFFFF"/>
                           </a:solidFill>
                           <a:latin typeface="Be Vietnam Pro" pitchFamily="34" charset="0"/>
                           <a:ea typeface="Be Vietnam Pro" pitchFamily="34" charset="-122"/>
@@ -8386,7 +8386,7 @@
                       <a:r>
                         <a:rPr lang="en-US" sz="2850" b="1" dirty="0" spc="-5" kern="0">
                           <a:solidFill>
-                            <a:srgbClr val="F3EEE3"/>
+                            <a:srgbClr val="FFFFFF"/>
                           </a:solidFill>
                           <a:latin typeface="Be Vietnam Pro" pitchFamily="34" charset="0"/>
                           <a:ea typeface="Be Vietnam Pro" pitchFamily="34" charset="-122"/>
@@ -8397,7 +8397,7 @@
                       <a:endParaRPr lang="en-US" sz="1200" dirty="0"/>
                     </a:p>
                   </a:txBody>
-                  <a:tcPr marL="228600" marR="228600" marT="228600" marB="228600">
+                  <a:tcPr marL="76200" marR="76200" marT="76200" marB="76200">
                     <a:lnL w="9525" cap="flat" cmpd="sng" algn="ctr">
                       <a:solidFill>
                         <a:srgbClr val="DDD5C1"/>
@@ -8435,7 +8435,7 @@
                       <a:r>
                         <a:rPr lang="en-US" sz="2850" b="1" dirty="0" spc="0" kern="0">
                           <a:solidFill>
-                            <a:srgbClr val="F3EEE3"/>
+                            <a:srgbClr val="FFFFFF"/>
                           </a:solidFill>
                           <a:latin typeface="Be Vietnam Pro" pitchFamily="34" charset="0"/>
                           <a:ea typeface="Be Vietnam Pro" pitchFamily="34" charset="-122"/>
@@ -8446,7 +8446,7 @@
                       <a:r>
                         <a:rPr lang="en-US" sz="2850" b="1" dirty="0" spc="-6" kern="0">
                           <a:solidFill>
-                            <a:srgbClr val="F3EEE3"/>
+                            <a:srgbClr val="FFFFFF"/>
                           </a:solidFill>
                           <a:latin typeface="Be Vietnam Pro" pitchFamily="34" charset="0"/>
                           <a:ea typeface="Be Vietnam Pro" pitchFamily="34" charset="-122"/>
@@ -8457,7 +8457,7 @@
                       <a:endParaRPr lang="en-US" sz="1200" dirty="0"/>
                     </a:p>
                   </a:txBody>
-                  <a:tcPr marL="228600" marR="228600" marT="228600" marB="228600">
+                  <a:tcPr marL="76200" marR="76200" marT="76200" marB="76200">
                     <a:lnL w="9525" cap="flat" cmpd="sng" algn="ctr">
                       <a:solidFill>
                         <a:srgbClr val="DDD5C1"/>
@@ -8536,7 +8536,7 @@
                       <a:endParaRPr lang="en-US" sz="1200" dirty="0"/>
                     </a:p>
                   </a:txBody>
-                  <a:tcPr marL="228600" marR="228600" marT="228600" marB="228600">
+                  <a:tcPr marL="76200" marR="76200" marT="76200" marB="76200">
                     <a:lnL w="9525" cap="flat" cmpd="sng" algn="ctr">
                       <a:solidFill>
                         <a:srgbClr val="DDD5C1"/>
@@ -8591,7 +8591,7 @@
                       <a:endParaRPr lang="en-US" sz="1200" dirty="0"/>
                     </a:p>
                   </a:txBody>
-                  <a:tcPr marL="228600" marR="228600" marT="228600" marB="228600">
+                  <a:tcPr marL="76200" marR="76200" marT="76200" marB="76200">
                     <a:lnL w="9525" cap="flat" cmpd="sng" algn="ctr">
                       <a:solidFill>
                         <a:srgbClr val="DDD5C1"/>
@@ -8646,7 +8646,7 @@
                       <a:endParaRPr lang="en-US" sz="1200" dirty="0"/>
                     </a:p>
                   </a:txBody>
-                  <a:tcPr marL="228600" marR="228600" marT="228600" marB="228600">
+                  <a:tcPr marL="76200" marR="76200" marT="76200" marB="76200">
                     <a:lnL w="9525" cap="flat" cmpd="sng" algn="ctr">
                       <a:solidFill>
                         <a:srgbClr val="DDD5C1"/>
@@ -8742,7 +8742,7 @@
                       <a:endParaRPr lang="en-US" sz="1200" dirty="0"/>
                     </a:p>
                   </a:txBody>
-                  <a:tcPr marL="228600" marR="228600" marT="228600" marB="228600">
+                  <a:tcPr marL="76200" marR="76200" marT="76200" marB="76200">
                     <a:lnL w="9525" cap="flat" cmpd="sng" algn="ctr">
                       <a:solidFill>
                         <a:srgbClr val="DDD5C1"/>
@@ -8797,7 +8797,7 @@
                       <a:endParaRPr lang="en-US" sz="1200" dirty="0"/>
                     </a:p>
                   </a:txBody>
-                  <a:tcPr marL="228600" marR="228600" marT="228600" marB="228600">
+                  <a:tcPr marL="76200" marR="76200" marT="76200" marB="76200">
                     <a:lnL w="9525" cap="flat" cmpd="sng" algn="ctr">
                       <a:solidFill>
                         <a:srgbClr val="DDD5C1"/>
@@ -8874,7 +8874,7 @@
                       <a:endParaRPr lang="en-US" sz="1200" dirty="0"/>
                     </a:p>
                   </a:txBody>
-                  <a:tcPr marL="228600" marR="228600" marT="228600" marB="228600">
+                  <a:tcPr marL="76200" marR="76200" marT="76200" marB="76200">
                     <a:lnL w="9525" cap="flat" cmpd="sng" algn="ctr">
                       <a:solidFill>
                         <a:srgbClr val="DDD5C1"/>
@@ -8924,7 +8924,7 @@
                         <a:buNone/>
                       </a:pPr>
                       <a:r>
-                        <a:rPr lang="en-US" sz="2850" b="1" dirty="0" spc="-3" kern="0">
+                        <a:rPr lang="en-US" sz="2850" b="1" dirty="0" spc="-5" kern="0">
                           <a:solidFill>
                             <a:srgbClr val="000000"/>
                           </a:solidFill>
@@ -8932,21 +8932,10 @@
                           <a:ea typeface="Be Vietnam Pro" pitchFamily="34" charset="-122"/>
                           <a:cs typeface="Be Vietnam Pro" pitchFamily="34" charset="-120"/>
                         </a:rPr>
-                        <a:t>Phiên</a:t>
+                        <a:t>Mã</a:t>
                       </a:r>
                       <a:r>
-                        <a:rPr lang="en-US" sz="2850" b="1" dirty="0" spc="3" kern="0">
-                          <a:solidFill>
-                            <a:srgbClr val="000000"/>
-                          </a:solidFill>
-                          <a:latin typeface="Be Vietnam Pro" pitchFamily="34" charset="0"/>
-                          <a:ea typeface="Be Vietnam Pro" pitchFamily="34" charset="-122"/>
-                          <a:cs typeface="Be Vietnam Pro" pitchFamily="34" charset="-120"/>
-                        </a:rPr>
-                        <a:t> bản</a:t>
-                      </a:r>
-                      <a:r>
-                        <a:rPr lang="en-US" sz="2850" b="1" dirty="0" spc="-1" kern="0">
+                        <a:rPr lang="en-US" sz="2850" b="1" dirty="0" spc="0" kern="0">
                           <a:solidFill>
                             <a:srgbClr val="000000"/>
                           </a:solidFill>
@@ -8967,10 +8956,32 @@
                         </a:rPr>
                         <a:t> lộn</a:t>
                       </a:r>
+                      <a:r>
+                        <a:rPr lang="en-US" sz="2850" b="1" dirty="0" spc="-3" kern="0">
+                          <a:solidFill>
+                            <a:srgbClr val="000000"/>
+                          </a:solidFill>
+                          <a:latin typeface="Be Vietnam Pro" pitchFamily="34" charset="0"/>
+                          <a:ea typeface="Be Vietnam Pro" pitchFamily="34" charset="-122"/>
+                          <a:cs typeface="Be Vietnam Pro" pitchFamily="34" charset="-120"/>
+                        </a:rPr>
+                        <a:t> phiên</a:t>
+                      </a:r>
+                      <a:r>
+                        <a:rPr lang="en-US" sz="2850" b="1" dirty="0" spc="2" kern="0">
+                          <a:solidFill>
+                            <a:srgbClr val="000000"/>
+                          </a:solidFill>
+                          <a:latin typeface="Be Vietnam Pro" pitchFamily="34" charset="0"/>
+                          <a:ea typeface="Be Vietnam Pro" pitchFamily="34" charset="-122"/>
+                          <a:cs typeface="Be Vietnam Pro" pitchFamily="34" charset="-120"/>
+                        </a:rPr>
+                        <a:t> bản</a:t>
+                      </a:r>
                       <a:endParaRPr lang="en-US" sz="1200" dirty="0"/>
                     </a:p>
                   </a:txBody>
-                  <a:tcPr marL="228600" marR="228600" marT="228600" marB="228600">
+                  <a:tcPr marL="76200" marR="76200" marT="76200" marB="76200">
                     <a:lnL w="9525" cap="flat" cmpd="sng" algn="ctr">
                       <a:solidFill>
                         <a:srgbClr val="DDD5C1"/>
@@ -9025,7 +9036,7 @@
                       <a:endParaRPr lang="en-US" sz="1200" dirty="0"/>
                     </a:p>
                   </a:txBody>
-                  <a:tcPr marL="228600" marR="228600" marT="228600" marB="228600">
+                  <a:tcPr marL="76200" marR="76200" marT="76200" marB="76200">
                     <a:lnL w="9525" cap="flat" cmpd="sng" algn="ctr">
                       <a:solidFill>
                         <a:srgbClr val="DDD5C1"/>
@@ -9135,7 +9146,7 @@
                       <a:endParaRPr lang="en-US" sz="1200" dirty="0"/>
                     </a:p>
                   </a:txBody>
-                  <a:tcPr marL="228600" marR="228600" marT="228600" marB="228600">
+                  <a:tcPr marL="76200" marR="76200" marT="76200" marB="76200">
                     <a:lnL w="9525" cap="flat" cmpd="sng" algn="ctr">
                       <a:solidFill>
                         <a:srgbClr val="DDD5C1"/>
@@ -9184,8 +9195,8 @@
         </p:nvSpPr>
         <p:spPr>
           <a:xfrm>
-            <a:off x="914400" y="8382000"/>
-            <a:ext cx="16192500" cy="476250"/>
+            <a:off x="914400" y="8191500"/>
+            <a:ext cx="16459200" cy="952500"/>
           </a:xfrm>
           <a:prstGeom prst="rect">
             <a:avLst/>
@@ -9194,13 +9205,115 @@
           <a:ln/>
         </p:spPr>
         <p:txBody>
-          <a:bodyPr wrap="square" lIns="0" tIns="0" rIns="0" bIns="0" rtlCol="0" anchor="t"/>
+          <a:bodyPr wrap="square" lIns="0" tIns="12144" rIns="0" bIns="-12144" rtlCol="0" anchor="t"/>
           <a:lstStyle/>
           <a:p>
             <a:pPr algn="l" indent="0" marL="0">
+              <a:lnSpc>
+                <a:spcPts val="2925"/>
+              </a:lnSpc>
               <a:buNone/>
             </a:pPr>
             <a:r>
+              <a:rPr lang="en-US" sz="2250" dirty="0" spc="-1" kern="0">
+                <a:solidFill>
+                  <a:srgbClr val="6B6A66"/>
+                </a:solidFill>
+                <a:latin typeface="Be Vietnam Pro" pitchFamily="34" charset="0"/>
+                <a:ea typeface="Be Vietnam Pro" pitchFamily="34" charset="-122"/>
+                <a:cs typeface="Be Vietnam Pro" pitchFamily="34" charset="-120"/>
+              </a:rPr>
+              <a:t>Bảng</a:t>
+            </a:r>
+            <a:r>
+              <a:rPr lang="en-US" sz="2250" dirty="0" spc="1" kern="0">
+                <a:solidFill>
+                  <a:srgbClr val="6B6A66"/>
+                </a:solidFill>
+                <a:latin typeface="Be Vietnam Pro" pitchFamily="34" charset="0"/>
+                <a:ea typeface="Be Vietnam Pro" pitchFamily="34" charset="-122"/>
+                <a:cs typeface="Be Vietnam Pro" pitchFamily="34" charset="-120"/>
+              </a:rPr>
+              <a:t> nói</a:t>
+            </a:r>
+            <a:r>
+              <a:rPr lang="en-US" sz="2250" dirty="0" spc="-16" kern="0">
+                <a:solidFill>
+                  <a:srgbClr val="6B6A66"/>
+                </a:solidFill>
+                <a:latin typeface="Be Vietnam Pro" pitchFamily="34" charset="0"/>
+                <a:ea typeface="Be Vietnam Pro" pitchFamily="34" charset="-122"/>
+                <a:cs typeface="Be Vietnam Pro" pitchFamily="34" charset="-120"/>
+              </a:rPr>
+              <a:t> về</a:t>
+            </a:r>
+            <a:r>
+              <a:rPr lang="en-US" sz="2250" dirty="0" spc="-1" kern="0">
+                <a:solidFill>
+                  <a:srgbClr val="6B6A66"/>
+                </a:solidFill>
+                <a:latin typeface="Be Vietnam Pro" pitchFamily="34" charset="0"/>
+                <a:ea typeface="Be Vietnam Pro" pitchFamily="34" charset="-122"/>
+                <a:cs typeface="Be Vietnam Pro" pitchFamily="34" charset="-120"/>
+              </a:rPr>
+              <a:t> mã</a:t>
+            </a:r>
+            <a:r>
+              <a:rPr lang="en-US" sz="2250" dirty="0" spc="-16" kern="0">
+                <a:solidFill>
+                  <a:srgbClr val="6B6A66"/>
+                </a:solidFill>
+                <a:latin typeface="Be Vietnam Pro" pitchFamily="34" charset="0"/>
+                <a:ea typeface="Be Vietnam Pro" pitchFamily="34" charset="-122"/>
+                <a:cs typeface="Be Vietnam Pro" pitchFamily="34" charset="-120"/>
+              </a:rPr>
+              <a:t> trong</a:t>
+            </a:r>
+            <a:r>
+              <a:rPr lang="en-US" sz="2250" dirty="0" spc="-2" kern="0">
+                <a:solidFill>
+                  <a:srgbClr val="6B6A66"/>
+                </a:solidFill>
+                <a:latin typeface="Be Vietnam Pro" pitchFamily="34" charset="0"/>
+                <a:ea typeface="Be Vietnam Pro" pitchFamily="34" charset="-122"/>
+                <a:cs typeface="Be Vietnam Pro" pitchFamily="34" charset="-120"/>
+              </a:rPr>
+              <a:t> kho,</a:t>
+            </a:r>
+            <a:r>
+              <a:rPr lang="en-US" sz="2250" dirty="0" spc="1" kern="0">
+                <a:solidFill>
+                  <a:srgbClr val="6B6A66"/>
+                </a:solidFill>
+                <a:latin typeface="Be Vietnam Pro" pitchFamily="34" charset="0"/>
+                <a:ea typeface="Be Vietnam Pro" pitchFamily="34" charset="-122"/>
+                <a:cs typeface="Be Vietnam Pro" pitchFamily="34" charset="-120"/>
+              </a:rPr>
+              <a:t> không</a:t>
+            </a:r>
+            <a:r>
+              <a:rPr lang="en-US" sz="2250" dirty="0" spc="-16" kern="0">
+                <a:solidFill>
+                  <a:srgbClr val="6B6A66"/>
+                </a:solidFill>
+                <a:latin typeface="Be Vietnam Pro" pitchFamily="34" charset="0"/>
+                <a:ea typeface="Be Vietnam Pro" pitchFamily="34" charset="-122"/>
+                <a:cs typeface="Be Vietnam Pro" pitchFamily="34" charset="-120"/>
+              </a:rPr>
+              <a:t> về</a:t>
+            </a:r>
+            <a:r>
+              <a:rPr lang="en-US" sz="2250" dirty="0" spc="6" kern="0">
+                <a:solidFill>
+                  <a:srgbClr val="6B6A66"/>
+                </a:solidFill>
+                <a:latin typeface="Be Vietnam Pro" pitchFamily="34" charset="0"/>
+                <a:ea typeface="Be Vietnam Pro" pitchFamily="34" charset="-122"/>
+                <a:cs typeface="Be Vietnam Pro" pitchFamily="34" charset="-120"/>
+              </a:rPr>
+              <a:t> triển</a:t>
+            </a:r>
+            <a:r>
               <a:rPr lang="en-US" sz="2250" dirty="0" spc="0" kern="0">
                 <a:solidFill>
                   <a:srgbClr val="6B6A66"/>
@@ -9209,7 +9322,150 @@
                 <a:ea typeface="Be Vietnam Pro" pitchFamily="34" charset="-122"/>
                 <a:cs typeface="Be Vietnam Pro" pitchFamily="34" charset="-120"/>
               </a:rPr>
-              <a:t>Phép</a:t>
+              <a:t> khai:</a:t>
+            </a:r>
+            <a:r>
+              <a:rPr lang="en-US" sz="2250" dirty="0" spc="1" kern="0">
+                <a:solidFill>
+                  <a:srgbClr val="6B6A66"/>
+                </a:solidFill>
+                <a:latin typeface="Be Vietnam Pro" pitchFamily="34" charset="0"/>
+                <a:ea typeface="Be Vietnam Pro" pitchFamily="34" charset="-122"/>
+                <a:cs typeface="Be Vietnam Pro" pitchFamily="34" charset="-120"/>
+              </a:rPr>
+              <a:t> dịch</a:t>
+            </a:r>
+            <a:r>
+              <a:rPr lang="en-US" sz="2250" dirty="0" spc="2" kern="0">
+                <a:solidFill>
+                  <a:srgbClr val="6B6A66"/>
+                </a:solidFill>
+                <a:latin typeface="Be Vietnam Pro" pitchFamily="34" charset="0"/>
+                <a:ea typeface="Be Vietnam Pro" pitchFamily="34" charset="-122"/>
+                <a:cs typeface="Be Vietnam Pro" pitchFamily="34" charset="-120"/>
+              </a:rPr>
+              <a:t> vụ</a:t>
+            </a:r>
+            <a:r>
+              <a:rPr lang="en-US" sz="2250" dirty="0" spc="6" kern="0">
+                <a:solidFill>
+                  <a:srgbClr val="6B6A66"/>
+                </a:solidFill>
+                <a:latin typeface="Be Vietnam Pro" pitchFamily="34" charset="0"/>
+                <a:ea typeface="Be Vietnam Pro" pitchFamily="34" charset="-122"/>
+                <a:cs typeface="Be Vietnam Pro" pitchFamily="34" charset="-120"/>
+              </a:rPr>
+              <a:t> triển</a:t>
+            </a:r>
+            <a:r>
+              <a:rPr lang="en-US" sz="2250" dirty="0" spc="-1" kern="0">
+                <a:solidFill>
+                  <a:srgbClr val="6B6A66"/>
+                </a:solidFill>
+                <a:latin typeface="Be Vietnam Pro" pitchFamily="34" charset="0"/>
+                <a:ea typeface="Be Vietnam Pro" pitchFamily="34" charset="-122"/>
+                <a:cs typeface="Be Vietnam Pro" pitchFamily="34" charset="-120"/>
+              </a:rPr>
+              <a:t> khai</a:t>
+            </a:r>
+            <a:r>
+              <a:rPr lang="en-US" sz="2250" dirty="0" spc="5" kern="0">
+                <a:solidFill>
+                  <a:srgbClr val="6B6A66"/>
+                </a:solidFill>
+                <a:latin typeface="Be Vietnam Pro" pitchFamily="34" charset="0"/>
+                <a:ea typeface="Be Vietnam Pro" pitchFamily="34" charset="-122"/>
+                <a:cs typeface="Be Vietnam Pro" pitchFamily="34" charset="-120"/>
+              </a:rPr>
+              <a:t> riêng</a:t>
+            </a:r>
+            <a:r>
+              <a:rPr lang="en-US" sz="2250" dirty="0" spc="-12" kern="0">
+                <a:solidFill>
+                  <a:srgbClr val="6B6A66"/>
+                </a:solidFill>
+                <a:latin typeface="Be Vietnam Pro" pitchFamily="34" charset="0"/>
+                <a:ea typeface="Be Vietnam Pro" pitchFamily="34" charset="-122"/>
+                <a:cs typeface="Be Vietnam Pro" pitchFamily="34" charset="-120"/>
+              </a:rPr>
+              <a:t> vẫn</a:t>
+            </a:r>
+            <a:r>
+              <a:rPr lang="en-US" sz="2250" dirty="0" spc="1" kern="0">
+                <a:solidFill>
+                  <a:srgbClr val="6B6A66"/>
+                </a:solidFill>
+                <a:latin typeface="Be Vietnam Pro" pitchFamily="34" charset="0"/>
+                <a:ea typeface="Be Vietnam Pro" pitchFamily="34" charset="-122"/>
+                <a:cs typeface="Be Vietnam Pro" pitchFamily="34" charset="-120"/>
+              </a:rPr>
+              <a:t> cần</a:t>
+            </a:r>
+            <a:r>
+              <a:rPr lang="en-US" sz="2250" dirty="0" spc="-7" kern="0">
+                <a:solidFill>
+                  <a:srgbClr val="6B6A66"/>
+                </a:solidFill>
+                <a:latin typeface="Be Vietnam Pro" pitchFamily="34" charset="0"/>
+                <a:ea typeface="Be Vietnam Pro" pitchFamily="34" charset="-122"/>
+                <a:cs typeface="Be Vietnam Pro" pitchFamily="34" charset="-120"/>
+              </a:rPr>
+              <a:t> thay</a:t>
+            </a:r>
+            <a:r>
+              <a:rPr lang="en-US" sz="2250" dirty="0" spc="13" kern="0">
+                <a:solidFill>
+                  <a:srgbClr val="6B6A66"/>
+                </a:solidFill>
+                <a:latin typeface="Be Vietnam Pro" pitchFamily="34" charset="0"/>
+                <a:ea typeface="Be Vietnam Pro" pitchFamily="34" charset="-122"/>
+                <a:cs typeface="Be Vietnam Pro" pitchFamily="34" charset="-120"/>
+              </a:rPr>
+              <a:t> đổi</a:t>
+            </a:r>
+            <a:r>
+              <a:rPr lang="en-US" sz="2250" dirty="0" spc="5" kern="0">
+                <a:solidFill>
+                  <a:srgbClr val="6B6A66"/>
+                </a:solidFill>
+                <a:latin typeface="Be Vietnam Pro" pitchFamily="34" charset="0"/>
+                <a:ea typeface="Be Vietnam Pro" pitchFamily="34" charset="-122"/>
+                <a:cs typeface="Be Vietnam Pro" pitchFamily="34" charset="-120"/>
+              </a:rPr>
+              <a:t> tương</a:t>
+            </a:r>
+            <a:r>
+              <a:rPr lang="en-US" sz="2250" dirty="0" spc="0" kern="0">
+                <a:solidFill>
+                  <a:srgbClr val="6B6A66"/>
+                </a:solidFill>
+                <a:latin typeface="Be Vietnam Pro" pitchFamily="34" charset="0"/>
+                <a:ea typeface="Be Vietnam Pro" pitchFamily="34" charset="-122"/>
+                <a:cs typeface="Be Vietnam Pro" pitchFamily="34" charset="-120"/>
+              </a:rPr>
+              <a:t> thích</a:t>
+            </a:r>
+            <a:r>
+              <a:rPr lang="en-US" sz="2250" dirty="0" spc="7" kern="0">
+                <a:solidFill>
+                  <a:srgbClr val="6B6A66"/>
+                </a:solidFill>
+                <a:latin typeface="Be Vietnam Pro" pitchFamily="34" charset="0"/>
+                <a:ea typeface="Be Vietnam Pro" pitchFamily="34" charset="-122"/>
+                <a:cs typeface="Be Vietnam Pro" pitchFamily="34" charset="-120"/>
+              </a:rPr>
+              <a:t> ngược.</a:t>
+            </a:r>
+            <a:r>
+              <a:rPr lang="en-US" sz="2250" dirty="0" spc="1" kern="0">
+                <a:solidFill>
+                  <a:srgbClr val="6B6A66"/>
+                </a:solidFill>
+                <a:latin typeface="Be Vietnam Pro" pitchFamily="34" charset="0"/>
+                <a:ea typeface="Be Vietnam Pro" pitchFamily="34" charset="-122"/>
+                <a:cs typeface="Be Vietnam Pro" pitchFamily="34" charset="-120"/>
+              </a:rPr>
+              <a:t> Phép</a:t>
             </a:r>
             <a:r>
               <a:rPr lang="en-US" sz="2250" dirty="0" spc="11" kern="0">
@@ -9234,6 +9490,17 @@
               <a:t> theo</a:t>
             </a:r>
             <a:r>
+              <a:rPr lang="en-US" sz="2250" dirty="0" spc="1" kern="0">
+                <a:solidFill>
+                  <a:srgbClr val="6B6A66"/>
+                </a:solidFill>
+                <a:latin typeface="Be Vietnam Pro" pitchFamily="34" charset="0"/>
+                <a:ea typeface="Be Vietnam Pro" pitchFamily="34" charset="-122"/>
+                <a:cs typeface="Be Vietnam Pro" pitchFamily="34" charset="-120"/>
+              </a:rPr>
+              <a:t> lập</a:t>
+            </a:r>
+            <a:r>
               <a:rPr lang="en-US" sz="2250" dirty="0" spc="0" kern="0">
                 <a:solidFill>
                   <a:srgbClr val="6B6A66"/>
@@ -9242,95 +9509,7 @@
                 <a:ea typeface="Be Vietnam Pro" pitchFamily="34" charset="-122"/>
                 <a:cs typeface="Be Vietnam Pro" pitchFamily="34" charset="-120"/>
               </a:rPr>
-              <a:t> lập</a:t>
-            </a:r>
-            <a:r>
-              <a:rPr lang="en-US" sz="2250" dirty="0" spc="-1" kern="0">
-                <a:solidFill>
-                  <a:srgbClr val="6B6A66"/>
-                </a:solidFill>
-                <a:latin typeface="Be Vietnam Pro" pitchFamily="34" charset="0"/>
-                <a:ea typeface="Be Vietnam Pro" pitchFamily="34" charset="-122"/>
-                <a:cs typeface="Be Vietnam Pro" pitchFamily="34" charset="-120"/>
-              </a:rPr>
-              <a:t> luận,</a:t>
-            </a:r>
-            <a:r>
-              <a:rPr lang="en-US" sz="2250" dirty="0" spc="1" kern="0">
-                <a:solidFill>
-                  <a:srgbClr val="6B6A66"/>
-                </a:solidFill>
-                <a:latin typeface="Be Vietnam Pro" pitchFamily="34" charset="0"/>
-                <a:ea typeface="Be Vietnam Pro" pitchFamily="34" charset="-122"/>
-                <a:cs typeface="Be Vietnam Pro" pitchFamily="34" charset="-120"/>
-              </a:rPr>
-              <a:t> không</a:t>
-            </a:r>
-            <a:r>
-              <a:rPr lang="en-US" sz="2250" dirty="0" spc="-1" kern="0">
-                <a:solidFill>
-                  <a:srgbClr val="6B6A66"/>
-                </a:solidFill>
-                <a:latin typeface="Be Vietnam Pro" pitchFamily="34" charset="0"/>
-                <a:ea typeface="Be Vietnam Pro" pitchFamily="34" charset="-122"/>
-                <a:cs typeface="Be Vietnam Pro" pitchFamily="34" charset="-120"/>
-              </a:rPr>
-              <a:t> phải</a:t>
-            </a:r>
-            <a:r>
-              <a:rPr lang="en-US" sz="2250" dirty="0" spc="16" kern="0">
-                <a:solidFill>
-                  <a:srgbClr val="6B6A66"/>
-                </a:solidFill>
-                <a:latin typeface="Be Vietnam Pro" pitchFamily="34" charset="0"/>
-                <a:ea typeface="Be Vietnam Pro" pitchFamily="34" charset="-122"/>
-                <a:cs typeface="Be Vietnam Pro" pitchFamily="34" charset="-120"/>
-              </a:rPr>
-              <a:t> đo</a:t>
-            </a:r>
-            <a:r>
-              <a:rPr lang="en-US" sz="2250" dirty="0" spc="5" kern="0">
-                <a:solidFill>
-                  <a:srgbClr val="6B6A66"/>
-                </a:solidFill>
-                <a:latin typeface="Be Vietnam Pro" pitchFamily="34" charset="0"/>
-                <a:ea typeface="Be Vietnam Pro" pitchFamily="34" charset="-122"/>
-                <a:cs typeface="Be Vietnam Pro" pitchFamily="34" charset="-120"/>
-              </a:rPr>
-              <a:t> ở</a:t>
-            </a:r>
-            <a:r>
-              <a:rPr lang="en-US" sz="2250" dirty="0" spc="2" kern="0">
-                <a:solidFill>
-                  <a:srgbClr val="6B6A66"/>
-                </a:solidFill>
-                <a:latin typeface="Be Vietnam Pro" pitchFamily="34" charset="0"/>
-                <a:ea typeface="Be Vietnam Pro" pitchFamily="34" charset="-122"/>
-                <a:cs typeface="Be Vietnam Pro" pitchFamily="34" charset="-120"/>
-              </a:rPr>
-              <a:t> công</a:t>
-            </a:r>
-            <a:r>
-              <a:rPr lang="en-US" sz="2250" dirty="0" spc="-5" kern="0">
-                <a:solidFill>
-                  <a:srgbClr val="6B6A66"/>
-                </a:solidFill>
-                <a:latin typeface="Be Vietnam Pro" pitchFamily="34" charset="0"/>
-                <a:ea typeface="Be Vietnam Pro" pitchFamily="34" charset="-122"/>
-                <a:cs typeface="Be Vietnam Pro" pitchFamily="34" charset="-120"/>
-              </a:rPr>
-              <a:t> ty</a:t>
-            </a:r>
-            <a:r>
-              <a:rPr lang="en-US" sz="2250" dirty="0" spc="-7" kern="0">
-                <a:solidFill>
-                  <a:srgbClr val="6B6A66"/>
-                </a:solidFill>
-                <a:latin typeface="Be Vietnam Pro" pitchFamily="34" charset="0"/>
-                <a:ea typeface="Be Vietnam Pro" pitchFamily="34" charset="-122"/>
-                <a:cs typeface="Be Vietnam Pro" pitchFamily="34" charset="-120"/>
-              </a:rPr>
-              <a:t> thật.</a:t>
+              <a:t> luận.</a:t>
             </a:r>
             <a:endParaRPr lang="en-US" sz="2250" dirty="0"/>
           </a:p>

</xml_diff>

<commit_message>
System Design vi: sd-11-018 unified library versions are a policy, not a property of one repository
Co-Authored-By: Claude Sonnet 5.5 <noreply@anthropic.com>
Claude-Session: https://claude.ai/code/session_01FUEjJx1iJbs8YafmDVXup4
</commit_message>
<xml_diff>
--- a/system-design-101/vi/lessons/sd-11-018/slides/sd-11-018.pptx
+++ b/system-design-101/vi/lessons/sd-11-018/slides/sd-11-018.pptx
@@ -3566,7 +3566,7 @@
         </p:nvSpPr>
         <p:spPr>
           <a:xfrm>
-            <a:off x="1257300" y="3400425"/>
+            <a:off x="1352550" y="3400425"/>
             <a:ext cx="914400" cy="914400"/>
           </a:xfrm>
           <a:prstGeom prst="ellipse">
@@ -3585,7 +3585,7 @@
               <a:buNone/>
             </a:pPr>
             <a:r>
-              <a:rPr lang="en-US" sz="3238" dirty="0" spc="4" kern="0">
+              <a:rPr lang="en-US" sz="3000" dirty="0" spc="5" kern="0">
                 <a:solidFill>
                   <a:srgbClr val="F3EEE3"/>
                 </a:solidFill>
@@ -3595,7 +3595,7 @@
               </a:rPr>
               <a:t>1</a:t>
             </a:r>
-            <a:endParaRPr lang="en-US" sz="3238" dirty="0"/>
+            <a:endParaRPr lang="en-US" sz="3000" dirty="0"/>
           </a:p>
         </p:txBody>
       </p:sp>
@@ -3607,8 +3607,8 @@
         </p:nvSpPr>
         <p:spPr>
           <a:xfrm>
-            <a:off x="2571750" y="3400425"/>
-            <a:ext cx="14287500" cy="914400"/>
+            <a:off x="2762250" y="3143250"/>
+            <a:ext cx="14287500" cy="1428750"/>
           </a:xfrm>
           <a:prstGeom prst="rect">
             <a:avLst/>
@@ -3624,7 +3624,7 @@
               <a:buNone/>
             </a:pPr>
             <a:r>
-              <a:rPr lang="en-US" sz="3150" dirty="0" spc="-12" kern="0">
+              <a:rPr lang="en-US" sz="2850" dirty="0" spc="-15" kern="0">
                 <a:solidFill>
                   <a:srgbClr val="14161C"/>
                 </a:solidFill>
@@ -3635,7 +3635,7 @@
               <a:t>Một</a:t>
             </a:r>
             <a:r>
-              <a:rPr lang="en-US" sz="3150" dirty="0" spc="-8" kern="0">
+              <a:rPr lang="en-US" sz="2850" dirty="0" spc="-10" kern="0">
                 <a:solidFill>
                   <a:srgbClr val="14161C"/>
                 </a:solidFill>
@@ -3646,7 +3646,7 @@
               <a:t> thay</a:t>
             </a:r>
             <a:r>
-              <a:rPr lang="en-US" sz="3150" dirty="0" spc="8" kern="0">
+              <a:rPr lang="en-US" sz="2850" dirty="0" spc="9" kern="0">
                 <a:solidFill>
                   <a:srgbClr val="14161C"/>
                 </a:solidFill>
@@ -3657,7 +3657,7 @@
               <a:t> đổi</a:t>
             </a:r>
             <a:r>
-              <a:rPr lang="en-US" sz="3150" dirty="0" spc="0" kern="0">
+              <a:rPr lang="en-US" sz="2850" dirty="0" spc="2" kern="0">
                 <a:solidFill>
                   <a:srgbClr val="14161C"/>
                 </a:solidFill>
@@ -3665,10 +3665,10 @@
                 <a:ea typeface="Be Vietnam Pro SemiBold" pitchFamily="34" charset="-122"/>
                 <a:cs typeface="Be Vietnam Pro SemiBold" pitchFamily="34" charset="-120"/>
               </a:rPr>
-              <a:t> chạm nhiều</a:t>
-            </a:r>
-            <a:r>
-              <a:rPr lang="en-US" sz="3150" dirty="0" spc="1" kern="0">
+              <a:t> chạm</a:t>
+            </a:r>
+            <a:r>
+              <a:rPr lang="en-US" sz="2850" dirty="0" spc="1" kern="0">
                 <a:solidFill>
                   <a:srgbClr val="14161C"/>
                 </a:solidFill>
@@ -3676,10 +3676,10 @@
                 <a:ea typeface="Be Vietnam Pro SemiBold" pitchFamily="34" charset="-122"/>
                 <a:cs typeface="Be Vietnam Pro SemiBold" pitchFamily="34" charset="-120"/>
               </a:rPr>
-              <a:t> dịch</a:t>
-            </a:r>
-            <a:r>
-              <a:rPr lang="en-US" sz="3150" dirty="0" spc="-1" kern="0">
+              <a:t> nhiều dịch</a:t>
+            </a:r>
+            <a:r>
+              <a:rPr lang="en-US" sz="2850" dirty="0" spc="3" kern="0">
                 <a:solidFill>
                   <a:srgbClr val="14161C"/>
                 </a:solidFill>
@@ -3690,7 +3690,7 @@
               <a:t> vụ</a:t>
             </a:r>
             <a:r>
-              <a:rPr lang="en-US" sz="3150" dirty="0" spc="-3" kern="0">
+              <a:rPr lang="en-US" sz="2850" dirty="0" spc="0" kern="0">
                 <a:solidFill>
                   <a:srgbClr val="14161C"/>
                 </a:solidFill>
@@ -3701,7 +3701,7 @@
               <a:t> nằm</a:t>
             </a:r>
             <a:r>
-              <a:rPr lang="en-US" sz="3150" dirty="0" spc="-19" kern="0">
+              <a:rPr lang="en-US" sz="2850" dirty="0" spc="-18" kern="0">
                 <a:solidFill>
                   <a:srgbClr val="14161C"/>
                 </a:solidFill>
@@ -3712,7 +3712,7 @@
               <a:t> trong</a:t>
             </a:r>
             <a:r>
-              <a:rPr lang="en-US" sz="3150" dirty="0" spc="-11" kern="0">
+              <a:rPr lang="en-US" sz="2850" dirty="0" spc="-10" kern="0">
                 <a:solidFill>
                   <a:srgbClr val="14161C"/>
                 </a:solidFill>
@@ -3723,7 +3723,7 @@
               <a:t> một</a:t>
             </a:r>
             <a:r>
-              <a:rPr lang="en-US" sz="3150" dirty="0" spc="-3" kern="0">
+              <a:rPr lang="en-US" sz="2850" dirty="0" spc="-3" kern="0">
                 <a:solidFill>
                   <a:srgbClr val="14161C"/>
                 </a:solidFill>
@@ -3733,7 +3733,7 @@
               </a:rPr>
               <a:t> commit.</a:t>
             </a:r>
-            <a:endParaRPr lang="en-US" sz="3150" dirty="0"/>
+            <a:endParaRPr lang="en-US" sz="2850" dirty="0"/>
           </a:p>
         </p:txBody>
       </p:sp>
@@ -3767,7 +3767,7 @@
         </p:nvSpPr>
         <p:spPr>
           <a:xfrm>
-            <a:off x="1257300" y="5114925"/>
+            <a:off x="1352550" y="5114925"/>
             <a:ext cx="914400" cy="914400"/>
           </a:xfrm>
           <a:prstGeom prst="ellipse">
@@ -3786,7 +3786,7 @@
               <a:buNone/>
             </a:pPr>
             <a:r>
-              <a:rPr lang="en-US" sz="3238" dirty="0" spc="-3" kern="0">
+              <a:rPr lang="en-US" sz="3000" dirty="0" spc="3" kern="0">
                 <a:solidFill>
                   <a:srgbClr val="F3EEE3"/>
                 </a:solidFill>
@@ -3796,7 +3796,7 @@
               </a:rPr>
               <a:t>2</a:t>
             </a:r>
-            <a:endParaRPr lang="en-US" sz="3238" dirty="0"/>
+            <a:endParaRPr lang="en-US" sz="3000" dirty="0"/>
           </a:p>
         </p:txBody>
       </p:sp>
@@ -3808,8 +3808,8 @@
         </p:nvSpPr>
         <p:spPr>
           <a:xfrm>
-            <a:off x="2571750" y="5114925"/>
-            <a:ext cx="14287500" cy="914400"/>
+            <a:off x="2762250" y="4857750"/>
+            <a:ext cx="14287500" cy="1428750"/>
           </a:xfrm>
           <a:prstGeom prst="rect">
             <a:avLst/>
@@ -3825,7 +3825,7 @@
               <a:buNone/>
             </a:pPr>
             <a:r>
-              <a:rPr lang="en-US" sz="3150" dirty="0" spc="2" kern="0">
+              <a:rPr lang="en-US" sz="2850" dirty="0" spc="0" kern="0">
                 <a:solidFill>
                   <a:srgbClr val="14161C"/>
                 </a:solidFill>
@@ -3833,10 +3833,10 @@
                 <a:ea typeface="Be Vietnam Pro SemiBold" pitchFamily="34" charset="-122"/>
                 <a:cs typeface="Be Vietnam Pro SemiBold" pitchFamily="34" charset="-120"/>
               </a:rPr>
-              <a:t>Cả</a:t>
-            </a:r>
-            <a:r>
-              <a:rPr lang="en-US" sz="3150" dirty="0" spc="-1" kern="0">
+              <a:t>Có</a:t>
+            </a:r>
+            <a:r>
+              <a:rPr lang="en-US" sz="2850" dirty="0" spc="-2" kern="0">
                 <a:solidFill>
                   <a:srgbClr val="14161C"/>
                 </a:solidFill>
@@ -3844,10 +3844,10 @@
                 <a:ea typeface="Be Vietnam Pro SemiBold" pitchFamily="34" charset="-122"/>
                 <a:cs typeface="Be Vietnam Pro SemiBold" pitchFamily="34" charset="-120"/>
               </a:rPr>
-              <a:t> kho</a:t>
-            </a:r>
-            <a:r>
-              <a:rPr lang="en-US" sz="3150" dirty="0" spc="7" kern="0">
+              <a:t> thể</a:t>
+            </a:r>
+            <a:r>
+              <a:rPr lang="en-US" sz="2850" dirty="0" spc="6" kern="0">
                 <a:solidFill>
                   <a:srgbClr val="14161C"/>
                 </a:solidFill>
@@ -3855,10 +3855,10 @@
                 <a:ea typeface="Be Vietnam Pro SemiBold" pitchFamily="34" charset="-122"/>
                 <a:cs typeface="Be Vietnam Pro SemiBold" pitchFamily="34" charset="-120"/>
               </a:rPr>
-              <a:t> thường</a:t>
-            </a:r>
-            <a:r>
-              <a:rPr lang="en-US" sz="3150" dirty="0" spc="-5" kern="0">
+              <a:t> áp</a:t>
+            </a:r>
+            <a:r>
+              <a:rPr lang="en-US" sz="2850" dirty="0" spc="-10" kern="0">
                 <a:solidFill>
                   <a:srgbClr val="14161C"/>
                 </a:solidFill>
@@ -3866,10 +3866,10 @@
                 <a:ea typeface="Be Vietnam Pro SemiBold" pitchFamily="34" charset="-122"/>
                 <a:cs typeface="Be Vietnam Pro SemiBold" pitchFamily="34" charset="-120"/>
               </a:rPr>
-              <a:t> dùng</a:t>
-            </a:r>
-            <a:r>
-              <a:rPr lang="en-US" sz="3150" dirty="0" spc="-1" kern="0">
+              <a:t> một</a:t>
+            </a:r>
+            <a:r>
+              <a:rPr lang="en-US" sz="2850" dirty="0" spc="-4" kern="0">
                 <a:solidFill>
                   <a:srgbClr val="14161C"/>
                 </a:solidFill>
@@ -3877,10 +3877,10 @@
                 <a:ea typeface="Be Vietnam Pro SemiBold" pitchFamily="34" charset="-122"/>
                 <a:cs typeface="Be Vietnam Pro SemiBold" pitchFamily="34" charset="-120"/>
               </a:rPr>
-              <a:t> chung</a:t>
-            </a:r>
-            <a:r>
-              <a:rPr lang="en-US" sz="3150" dirty="0" spc="-11" kern="0">
+              <a:t> phiên</a:t>
+            </a:r>
+            <a:r>
+              <a:rPr lang="en-US" sz="2850" dirty="0" spc="-1" kern="0">
                 <a:solidFill>
                   <a:srgbClr val="14161C"/>
                 </a:solidFill>
@@ -3888,10 +3888,10 @@
                 <a:ea typeface="Be Vietnam Pro SemiBold" pitchFamily="34" charset="-122"/>
                 <a:cs typeface="Be Vietnam Pro SemiBold" pitchFamily="34" charset="-120"/>
               </a:rPr>
-              <a:t> một</a:t>
-            </a:r>
-            <a:r>
-              <a:rPr lang="en-US" sz="3150" dirty="0" spc="-5" kern="0">
+              <a:t> bản</a:t>
+            </a:r>
+            <a:r>
+              <a:rPr lang="en-US" sz="2850" dirty="0" spc="0" kern="0">
                 <a:solidFill>
                   <a:srgbClr val="14161C"/>
                 </a:solidFill>
@@ -3899,10 +3899,10 @@
                 <a:ea typeface="Be Vietnam Pro SemiBold" pitchFamily="34" charset="-122"/>
                 <a:cs typeface="Be Vietnam Pro SemiBold" pitchFamily="34" charset="-120"/>
               </a:rPr>
-              <a:t> phiên</a:t>
-            </a:r>
-            <a:r>
-              <a:rPr lang="en-US" sz="3150" dirty="0" spc="-3" kern="0">
+              <a:t> thư</a:t>
+            </a:r>
+            <a:r>
+              <a:rPr lang="en-US" sz="2850" dirty="0" spc="-2" kern="0">
                 <a:solidFill>
                   <a:srgbClr val="14161C"/>
                 </a:solidFill>
@@ -3910,10 +3910,10 @@
                 <a:ea typeface="Be Vietnam Pro SemiBold" pitchFamily="34" charset="-122"/>
                 <a:cs typeface="Be Vietnam Pro SemiBold" pitchFamily="34" charset="-120"/>
               </a:rPr>
-              <a:t> bản</a:t>
-            </a:r>
-            <a:r>
-              <a:rPr lang="en-US" sz="3150" dirty="0" spc="1" kern="0">
+              <a:t> viện</a:t>
+            </a:r>
+            <a:r>
+              <a:rPr lang="en-US" sz="2850" dirty="0" spc="-1" kern="0">
                 <a:solidFill>
                   <a:srgbClr val="14161C"/>
                 </a:solidFill>
@@ -3921,10 +3921,10 @@
                 <a:ea typeface="Be Vietnam Pro SemiBold" pitchFamily="34" charset="-122"/>
                 <a:cs typeface="Be Vietnam Pro SemiBold" pitchFamily="34" charset="-120"/>
               </a:rPr>
-              <a:t> thư</a:t>
-            </a:r>
-            <a:r>
-              <a:rPr lang="en-US" sz="3150" dirty="0" spc="-2" kern="0">
+              <a:t> chung:</a:t>
+            </a:r>
+            <a:r>
+              <a:rPr lang="en-US" sz="2850" dirty="0" spc="13" kern="0">
                 <a:solidFill>
                   <a:srgbClr val="14161C"/>
                 </a:solidFill>
@@ -3932,9 +3932,42 @@
                 <a:ea typeface="Be Vietnam Pro SemiBold" pitchFamily="34" charset="-122"/>
                 <a:cs typeface="Be Vietnam Pro SemiBold" pitchFamily="34" charset="-120"/>
               </a:rPr>
-              <a:t> viện.</a:t>
-            </a:r>
-            <a:endParaRPr lang="en-US" sz="3150" dirty="0"/>
+              <a:t> đó</a:t>
+            </a:r>
+            <a:r>
+              <a:rPr lang="en-US" sz="2850" dirty="0" spc="1" kern="0">
+                <a:solidFill>
+                  <a:srgbClr val="14161C"/>
+                </a:solidFill>
+                <a:latin typeface="Be Vietnam Pro SemiBold" pitchFamily="34" charset="0"/>
+                <a:ea typeface="Be Vietnam Pro SemiBold" pitchFamily="34" charset="-122"/>
+                <a:cs typeface="Be Vietnam Pro SemiBold" pitchFamily="34" charset="-120"/>
+              </a:rPr>
+              <a:t> là</a:t>
+            </a:r>
+            <a:r>
+              <a:rPr lang="en-US" sz="2850" dirty="0" spc="0" kern="0">
+                <a:solidFill>
+                  <a:srgbClr val="14161C"/>
+                </a:solidFill>
+                <a:latin typeface="Be Vietnam Pro SemiBold" pitchFamily="34" charset="0"/>
+                <a:ea typeface="Be Vietnam Pro SemiBold" pitchFamily="34" charset="-122"/>
+                <a:cs typeface="Be Vietnam Pro SemiBold" pitchFamily="34" charset="-120"/>
+              </a:rPr>
+              <a:t> chính</a:t>
+            </a:r>
+            <a:r>
+              <a:rPr lang="en-US" sz="2850" dirty="0" spc="1" kern="0">
+                <a:solidFill>
+                  <a:srgbClr val="14161C"/>
+                </a:solidFill>
+                <a:latin typeface="Be Vietnam Pro SemiBold" pitchFamily="34" charset="0"/>
+                <a:ea typeface="Be Vietnam Pro SemiBold" pitchFamily="34" charset="-122"/>
+                <a:cs typeface="Be Vietnam Pro SemiBold" pitchFamily="34" charset="-120"/>
+              </a:rPr>
+              <a:t> sách.</a:t>
+            </a:r>
+            <a:endParaRPr lang="en-US" sz="2850" dirty="0"/>
           </a:p>
         </p:txBody>
       </p:sp>
@@ -3968,7 +4001,7 @@
         </p:nvSpPr>
         <p:spPr>
           <a:xfrm>
-            <a:off x="1257300" y="6829425"/>
+            <a:off x="1352550" y="6829425"/>
             <a:ext cx="914400" cy="914400"/>
           </a:xfrm>
           <a:prstGeom prst="ellipse">
@@ -3987,7 +4020,7 @@
               <a:buNone/>
             </a:pPr>
             <a:r>
-              <a:rPr lang="en-US" sz="3238" dirty="0" spc="4" kern="0">
+              <a:rPr lang="en-US" sz="3000" dirty="0" spc="-5" kern="0">
                 <a:solidFill>
                   <a:srgbClr val="F3EEE3"/>
                 </a:solidFill>
@@ -3997,7 +4030,7 @@
               </a:rPr>
               <a:t>3</a:t>
             </a:r>
-            <a:endParaRPr lang="en-US" sz="3238" dirty="0"/>
+            <a:endParaRPr lang="en-US" sz="3000" dirty="0"/>
           </a:p>
         </p:txBody>
       </p:sp>
@@ -4009,8 +4042,8 @@
         </p:nvSpPr>
         <p:spPr>
           <a:xfrm>
-            <a:off x="2571750" y="6829425"/>
-            <a:ext cx="14287500" cy="914400"/>
+            <a:off x="2762250" y="6572250"/>
+            <a:ext cx="14287500" cy="1428750"/>
           </a:xfrm>
           <a:prstGeom prst="rect">
             <a:avLst/>
@@ -4026,7 +4059,7 @@
               <a:buNone/>
             </a:pPr>
             <a:r>
-              <a:rPr lang="en-US" sz="3150" dirty="0" spc="3" kern="0">
+              <a:rPr lang="en-US" sz="2850" dirty="0" spc="5" kern="0">
                 <a:solidFill>
                   <a:srgbClr val="14161C"/>
                 </a:solidFill>
@@ -4037,7 +4070,7 @@
               <a:t>Cái</a:t>
             </a:r>
             <a:r>
-              <a:rPr lang="en-US" sz="3150" dirty="0" spc="1" kern="0">
+              <a:rPr lang="en-US" sz="2850" dirty="0" spc="2" kern="0">
                 <a:solidFill>
                   <a:srgbClr val="14161C"/>
                 </a:solidFill>
@@ -4048,7 +4081,7 @@
               <a:t> giá:</a:t>
             </a:r>
             <a:r>
-              <a:rPr lang="en-US" sz="3150" dirty="0" spc="-8" kern="0">
+              <a:rPr lang="en-US" sz="2850" dirty="0" spc="-7" kern="0">
                 <a:solidFill>
                   <a:srgbClr val="14161C"/>
                 </a:solidFill>
@@ -4059,7 +4092,7 @@
               <a:t> công</a:t>
             </a:r>
             <a:r>
-              <a:rPr lang="en-US" sz="3150" dirty="0" spc="0" kern="0">
+              <a:rPr lang="en-US" sz="2850" dirty="0" spc="4" kern="0">
                 <a:solidFill>
                   <a:srgbClr val="14161C"/>
                 </a:solidFill>
@@ -4070,7 +4103,7 @@
               <a:t> cụ</a:t>
             </a:r>
             <a:r>
-              <a:rPr lang="en-US" sz="3150" dirty="0" spc="-3" kern="0">
+              <a:rPr lang="en-US" sz="2850" dirty="0" spc="0" kern="0">
                 <a:solidFill>
                   <a:srgbClr val="14161C"/>
                 </a:solidFill>
@@ -4081,7 +4114,7 @@
               <a:t> build</a:t>
             </a:r>
             <a:r>
-              <a:rPr lang="en-US" sz="3150" dirty="0" spc="-23" kern="0">
+              <a:rPr lang="en-US" sz="2850" dirty="0" spc="-18" kern="0">
                 <a:solidFill>
                   <a:srgbClr val="14161C"/>
                 </a:solidFill>
@@ -4092,7 +4125,7 @@
               <a:t> và</a:t>
             </a:r>
             <a:r>
-              <a:rPr lang="en-US" sz="3150" dirty="0" spc="-2" kern="0">
+              <a:rPr lang="en-US" sz="2850" dirty="0" spc="1" kern="0">
                 <a:solidFill>
                   <a:srgbClr val="14161C"/>
                 </a:solidFill>
@@ -4100,10 +4133,10 @@
                 <a:ea typeface="Be Vietnam Pro SemiBold" pitchFamily="34" charset="-122"/>
                 <a:cs typeface="Be Vietnam Pro SemiBold" pitchFamily="34" charset="-120"/>
               </a:rPr>
-              <a:t> cơ chế</a:t>
-            </a:r>
-            <a:r>
-              <a:rPr lang="en-US" sz="3150" dirty="0" spc="-6" kern="0">
+              <a:t> cơ</a:t>
+            </a:r>
+            <a:r>
+              <a:rPr lang="en-US" sz="2850" dirty="0" spc="-1" kern="0">
                 <a:solidFill>
                   <a:srgbClr val="14161C"/>
                 </a:solidFill>
@@ -4111,10 +4144,10 @@
                 <a:ea typeface="Be Vietnam Pro SemiBold" pitchFamily="34" charset="-122"/>
                 <a:cs typeface="Be Vietnam Pro SemiBold" pitchFamily="34" charset="-120"/>
               </a:rPr>
-              <a:t> sở</a:t>
-            </a:r>
-            <a:r>
-              <a:rPr lang="en-US" sz="3150" dirty="0" spc="37" kern="0">
+              <a:t> chế</a:t>
+            </a:r>
+            <a:r>
+              <a:rPr lang="en-US" sz="2850" dirty="0" spc="-4" kern="0">
                 <a:solidFill>
                   <a:srgbClr val="14161C"/>
                 </a:solidFill>
@@ -4122,10 +4155,10 @@
                 <a:ea typeface="Be Vietnam Pro SemiBold" pitchFamily="34" charset="-122"/>
                 <a:cs typeface="Be Vietnam Pro SemiBold" pitchFamily="34" charset="-120"/>
               </a:rPr>
-              <a:t> hữu</a:t>
-            </a:r>
-            <a:r>
-              <a:rPr lang="en-US" sz="3150" dirty="0" spc="1" kern="0">
+              <a:t> sở</a:t>
+            </a:r>
+            <a:r>
+              <a:rPr lang="en-US" sz="2850" dirty="0" spc="36" kern="0">
                 <a:solidFill>
                   <a:srgbClr val="14161C"/>
                 </a:solidFill>
@@ -4133,10 +4166,10 @@
                 <a:ea typeface="Be Vietnam Pro SemiBold" pitchFamily="34" charset="-122"/>
                 <a:cs typeface="Be Vietnam Pro SemiBold" pitchFamily="34" charset="-120"/>
               </a:rPr>
-              <a:t> thư</a:t>
-            </a:r>
-            <a:r>
-              <a:rPr lang="en-US" sz="3150" dirty="0" spc="0" kern="0">
+              <a:t> hữu</a:t>
+            </a:r>
+            <a:r>
+              <a:rPr lang="en-US" sz="2850" dirty="0" spc="0" kern="0">
                 <a:solidFill>
                   <a:srgbClr val="14161C"/>
                 </a:solidFill>
@@ -4144,9 +4177,20 @@
                 <a:ea typeface="Be Vietnam Pro SemiBold" pitchFamily="34" charset="-122"/>
                 <a:cs typeface="Be Vietnam Pro SemiBold" pitchFamily="34" charset="-120"/>
               </a:rPr>
+              <a:t> thư</a:t>
+            </a:r>
+            <a:r>
+              <a:rPr lang="en-US" sz="2850" dirty="0" spc="2" kern="0">
+                <a:solidFill>
+                  <a:srgbClr val="14161C"/>
+                </a:solidFill>
+                <a:latin typeface="Be Vietnam Pro SemiBold" pitchFamily="34" charset="0"/>
+                <a:ea typeface="Be Vietnam Pro SemiBold" pitchFamily="34" charset="-122"/>
+                <a:cs typeface="Be Vietnam Pro SemiBold" pitchFamily="34" charset="-120"/>
+              </a:rPr>
               <a:t> mục.</a:t>
             </a:r>
-            <a:endParaRPr lang="en-US" sz="3150" dirty="0"/>
+            <a:endParaRPr lang="en-US" sz="2850" dirty="0"/>
           </a:p>
         </p:txBody>
       </p:sp>

</xml_diff>